<commit_message>
Update to session 6 slides to add some animations.
</commit_message>
<xml_diff>
--- a/canvas_material/lectures/powerpoint/Session06-Convergence.pptx
+++ b/canvas_material/lectures/powerpoint/Session06-Convergence.pptx
@@ -2016,7 +2016,7 @@
           <a:p>
             <a:r>
               <a:rPr lang="en-US" dirty="0"/>
-              <a:t>First calibration candidate — walk the evaluation aloud. It's tempting because it's easy and finishable, which is exactly the trap: high do-ability seduces. Score it live — low value (the need is already met), fails richness (one component, nothing to hand a contributor). It lands bottom-right on the 2x2, and low value means drop regardless of how quick it is. Set up the contrast: the next candidate is the opposite shape.</a:t>
+              <a:t>First calibration candidate, scored live rather than revealed. Read the idea, then ask the room for each verdict before you click it in: value, then do-ability, then richness — three clicks, one card each, and the ratings come up in plain ink so nobody reads the answer off the color. Click four colors all three at once, which is the moment the shape of the thing shows: one green in the middle, red on both sides. Then the last click lands the conclusion. It's tempting because it's easy and finishable, which is exactly the trap — high do-ability seduces. Low value means drop regardless of how quick it is. Set up the contrast: the next candidate is the opposite shape.</a:t>
             </a:r>
             <a:endParaRPr lang="en-US" dirty="0"/>
           </a:p>
@@ -2104,7 +2104,7 @@
           <a:p>
             <a:r>
               <a:rPr lang="en-US" dirty="0"/>
-              <a:t>Second candidate — the opposite shape, and the one that teaches the lesson. Don't describe it by scope or team size; describe it by the work. Read the six build components: each is a serious subsystem, which is exactly why richness is very high and do-ability, as-is, is low — no single team ships all of that soon. High value plus low do-ability lands top-left: the 2x2 says narrow or spike, not drop. Next slide does the narrowing.</a:t>
+              <a:t>Second candidate — the opposite shape, and the one that teaches the lesson. Same live scoring as the last slide: read the six build components first, then take each verdict from the room before clicking it in — value, do-ability, richness — and click the conclusion last. Don't describe it by scope or team size; describe it by the work. Read the six build components: each is a serious subsystem, which is exactly why richness is very high and do-ability, as-is, is low — no single team ships all of that soon. High value plus low do-ability lands top-left: the 2x2 says narrow or spike, not drop. Next slide does the narrowing.</a:t>
             </a:r>
             <a:endParaRPr lang="en-US" dirty="0"/>
           </a:p>
@@ -16627,7 +16627,7 @@
                 <a:ea typeface="Cambria" pitchFamily="34" charset="-122"/>
                 <a:cs typeface="Cambria" pitchFamily="34" charset="-120"/>
               </a:rPr>
-              <a:t>ClassClock — thin, but easy</a:t>
+              <a:t>ClassClock</a:t>
             </a:r>
             <a:endParaRPr lang="en-US" sz="3100" dirty="0"/>
           </a:p>
@@ -16765,7 +16765,7 @@
             </a:avLst>
           </a:prstGeom>
           <a:solidFill>
-            <a:srgbClr val="FBECE8"/>
+            <a:srgbClr val="F2F6F8"/>
           </a:solidFill>
           <a:ln/>
           <a:effectLst>
@@ -16818,7 +16818,7 @@
       </p:sp>
       <p:sp>
         <p:nvSpPr>
-          <p:cNvPr id="11" name="Text 8"/>
+          <p:cNvPr id="11" name="click-1"/>
           <p:cNvSpPr/>
           <p:nvPr/>
         </p:nvSpPr>
@@ -16843,7 +16843,7 @@
             <a:r>
               <a:rPr lang="en-US" sz="2600" b="1" dirty="0">
                 <a:solidFill>
-                  <a:srgbClr val="D9614C"/>
+                  <a:srgbClr val="1E2A36"/>
                 </a:solidFill>
                 <a:latin typeface="Cambria" pitchFamily="34" charset="0"/>
                 <a:ea typeface="Cambria" pitchFamily="34" charset="-122"/>
@@ -16857,7 +16857,7 @@
       </p:sp>
       <p:sp>
         <p:nvSpPr>
-          <p:cNvPr id="12" name="Text 9"/>
+          <p:cNvPr id="12" name="click-1"/>
           <p:cNvSpPr/>
           <p:nvPr/>
         </p:nvSpPr>
@@ -16914,7 +16914,7 @@
             </a:avLst>
           </a:prstGeom>
           <a:solidFill>
-            <a:srgbClr val="EAF4EE"/>
+            <a:srgbClr val="F2F6F8"/>
           </a:solidFill>
           <a:ln/>
           <a:effectLst>
@@ -16967,7 +16967,7 @@
       </p:sp>
       <p:sp>
         <p:nvSpPr>
-          <p:cNvPr id="15" name="Text 12"/>
+          <p:cNvPr id="15" name="click-2"/>
           <p:cNvSpPr/>
           <p:nvPr/>
         </p:nvSpPr>
@@ -16992,7 +16992,7 @@
             <a:r>
               <a:rPr lang="en-US" sz="2600" b="1" dirty="0">
                 <a:solidFill>
-                  <a:srgbClr val="3E9C6B"/>
+                  <a:srgbClr val="1E2A36"/>
                 </a:solidFill>
                 <a:latin typeface="Cambria" pitchFamily="34" charset="0"/>
                 <a:ea typeface="Cambria" pitchFamily="34" charset="-122"/>
@@ -17006,7 +17006,7 @@
       </p:sp>
       <p:sp>
         <p:nvSpPr>
-          <p:cNvPr id="16" name="Text 13"/>
+          <p:cNvPr id="16" name="click-2"/>
           <p:cNvSpPr/>
           <p:nvPr/>
         </p:nvSpPr>
@@ -17063,7 +17063,7 @@
             </a:avLst>
           </a:prstGeom>
           <a:solidFill>
-            <a:srgbClr val="FBECE8"/>
+            <a:srgbClr val="F2F6F8"/>
           </a:solidFill>
           <a:ln/>
           <a:effectLst>
@@ -17116,7 +17116,7 @@
       </p:sp>
       <p:sp>
         <p:nvSpPr>
-          <p:cNvPr id="19" name="Text 16"/>
+          <p:cNvPr id="19" name="click-3"/>
           <p:cNvSpPr/>
           <p:nvPr/>
         </p:nvSpPr>
@@ -17141,7 +17141,7 @@
             <a:r>
               <a:rPr lang="en-US" sz="2600" b="1" dirty="0">
                 <a:solidFill>
-                  <a:srgbClr val="D9614C"/>
+                  <a:srgbClr val="1E2A36"/>
                 </a:solidFill>
                 <a:latin typeface="Cambria" pitchFamily="34" charset="0"/>
                 <a:ea typeface="Cambria" pitchFamily="34" charset="-122"/>
@@ -17155,7 +17155,7 @@
       </p:sp>
       <p:sp>
         <p:nvSpPr>
-          <p:cNvPr id="20" name="Text 17"/>
+          <p:cNvPr id="20" name="click-3"/>
           <p:cNvSpPr/>
           <p:nvPr/>
         </p:nvSpPr>
@@ -17197,22 +17197,22 @@
       </p:sp>
       <p:sp>
         <p:nvSpPr>
-          <p:cNvPr id="21" name="Shape 18"/>
-          <p:cNvSpPr/>
-          <p:nvPr/>
-        </p:nvSpPr>
-        <p:spPr>
-          <a:xfrm>
-            <a:off x="548640" y="5349240"/>
-            <a:ext cx="11064240" cy="822960"/>
+          <p:cNvPr id="21" name="click-4"/>
+          <p:cNvSpPr/>
+          <p:nvPr/>
+        </p:nvSpPr>
+        <p:spPr>
+          <a:xfrm>
+            <a:off x="548640" y="2834640"/>
+            <a:ext cx="3511296" cy="2286000"/>
           </a:xfrm>
           <a:prstGeom prst="roundRect">
             <a:avLst>
-              <a:gd name="adj" fmla="val 10000"/>
+              <a:gd name="adj" fmla="val 3600"/>
             </a:avLst>
           </a:prstGeom>
           <a:solidFill>
-            <a:srgbClr val="14233A"/>
+            <a:srgbClr val="FBECE8"/>
           </a:solidFill>
           <a:ln/>
           <a:effectLst>
@@ -17226,7 +17226,454 @@
       </p:sp>
       <p:sp>
         <p:nvSpPr>
-          <p:cNvPr id="22" name="Shape 19"/>
+          <p:cNvPr id="22" name="click-4"/>
+          <p:cNvSpPr/>
+          <p:nvPr/>
+        </p:nvSpPr>
+        <p:spPr>
+          <a:xfrm>
+            <a:off x="804672" y="3035808"/>
+            <a:ext cx="2999232" cy="402336"/>
+          </a:xfrm>
+          <a:prstGeom prst="rect">
+            <a:avLst/>
+          </a:prstGeom>
+          <a:noFill/>
+          <a:ln/>
+        </p:spPr>
+        <p:txBody>
+          <a:bodyPr wrap="square" lIns="0" tIns="0" rIns="0" bIns="0" rtlCol="0" anchor="ctr"/>
+          <a:lstStyle/>
+          <a:p>
+            <a:pPr indent="0" marL="0">
+              <a:buNone/>
+            </a:pPr>
+            <a:r>
+              <a:rPr lang="en-US" sz="1400" b="1" spc="100" kern="0" dirty="0">
+                <a:solidFill>
+                  <a:srgbClr val="5F7284"/>
+                </a:solidFill>
+                <a:latin typeface="Calibri" pitchFamily="34" charset="0"/>
+                <a:ea typeface="Calibri" pitchFamily="34" charset="-122"/>
+                <a:cs typeface="Calibri" pitchFamily="34" charset="-120"/>
+              </a:rPr>
+              <a:t>Value</a:t>
+            </a:r>
+            <a:endParaRPr lang="en-US" sz="1400" dirty="0"/>
+          </a:p>
+        </p:txBody>
+      </p:sp>
+      <p:sp>
+        <p:nvSpPr>
+          <p:cNvPr id="23" name="click-4"/>
+          <p:cNvSpPr/>
+          <p:nvPr/>
+        </p:nvSpPr>
+        <p:spPr>
+          <a:xfrm>
+            <a:off x="804672" y="3419856"/>
+            <a:ext cx="2999232" cy="548640"/>
+          </a:xfrm>
+          <a:prstGeom prst="rect">
+            <a:avLst/>
+          </a:prstGeom>
+          <a:noFill/>
+          <a:ln/>
+        </p:spPr>
+        <p:txBody>
+          <a:bodyPr wrap="square" lIns="0" tIns="0" rIns="0" bIns="0" rtlCol="0" anchor="ctr"/>
+          <a:lstStyle/>
+          <a:p>
+            <a:pPr indent="0" marL="0">
+              <a:buNone/>
+            </a:pPr>
+            <a:r>
+              <a:rPr lang="en-US" sz="2600" b="1" dirty="0">
+                <a:solidFill>
+                  <a:srgbClr val="D9614C"/>
+                </a:solidFill>
+                <a:latin typeface="Cambria" pitchFamily="34" charset="0"/>
+                <a:ea typeface="Cambria" pitchFamily="34" charset="-122"/>
+                <a:cs typeface="Cambria" pitchFamily="34" charset="-120"/>
+              </a:rPr>
+              <a:t>LOW</a:t>
+            </a:r>
+            <a:endParaRPr lang="en-US" sz="2600" dirty="0"/>
+          </a:p>
+        </p:txBody>
+      </p:sp>
+      <p:sp>
+        <p:nvSpPr>
+          <p:cNvPr id="24" name="click-4"/>
+          <p:cNvSpPr/>
+          <p:nvPr/>
+        </p:nvSpPr>
+        <p:spPr>
+          <a:xfrm>
+            <a:off x="804672" y="4041648"/>
+            <a:ext cx="2999232" cy="960120"/>
+          </a:xfrm>
+          <a:prstGeom prst="rect">
+            <a:avLst/>
+          </a:prstGeom>
+          <a:noFill/>
+          <a:ln/>
+        </p:spPr>
+        <p:txBody>
+          <a:bodyPr wrap="square" lIns="0" tIns="0" rIns="0" bIns="0" rtlCol="0" anchor="t"/>
+          <a:lstStyle/>
+          <a:p>
+            <a:pPr indent="0" marL="0">
+              <a:lnSpc>
+                <a:spcPct val="106000"/>
+              </a:lnSpc>
+              <a:buNone/>
+            </a:pPr>
+            <a:r>
+              <a:rPr lang="en-US" sz="1400" dirty="0">
+                <a:solidFill>
+                  <a:srgbClr val="1E2A36"/>
+                </a:solidFill>
+                <a:latin typeface="Calibri" pitchFamily="34" charset="0"/>
+                <a:ea typeface="Calibri" pitchFamily="34" charset="-122"/>
+                <a:cs typeface="Calibri" pitchFamily="34" charset="-120"/>
+              </a:rPr>
+              <a:t>Your phone calendar already does this. No unmet need.</a:t>
+            </a:r>
+            <a:endParaRPr lang="en-US" sz="1400" dirty="0"/>
+          </a:p>
+        </p:txBody>
+      </p:sp>
+      <p:sp>
+        <p:nvSpPr>
+          <p:cNvPr id="25" name="click-4"/>
+          <p:cNvSpPr/>
+          <p:nvPr/>
+        </p:nvSpPr>
+        <p:spPr>
+          <a:xfrm>
+            <a:off x="4233672" y="2834640"/>
+            <a:ext cx="3511296" cy="2286000"/>
+          </a:xfrm>
+          <a:prstGeom prst="roundRect">
+            <a:avLst>
+              <a:gd name="adj" fmla="val 3600"/>
+            </a:avLst>
+          </a:prstGeom>
+          <a:solidFill>
+            <a:srgbClr val="EAF4EE"/>
+          </a:solidFill>
+          <a:ln/>
+          <a:effectLst>
+            <a:outerShdw sx="100000" sy="100000" kx="0" ky="0" algn="bl" rotWithShape="0" blurRad="88900" dist="38100" dir="5400000">
+              <a:srgbClr val="000000">
+                <a:alpha val="13000"/>
+              </a:srgbClr>
+            </a:outerShdw>
+          </a:effectLst>
+        </p:spPr>
+      </p:sp>
+      <p:sp>
+        <p:nvSpPr>
+          <p:cNvPr id="26" name="click-4"/>
+          <p:cNvSpPr/>
+          <p:nvPr/>
+        </p:nvSpPr>
+        <p:spPr>
+          <a:xfrm>
+            <a:off x="4489704" y="3035808"/>
+            <a:ext cx="2999232" cy="402336"/>
+          </a:xfrm>
+          <a:prstGeom prst="rect">
+            <a:avLst/>
+          </a:prstGeom>
+          <a:noFill/>
+          <a:ln/>
+        </p:spPr>
+        <p:txBody>
+          <a:bodyPr wrap="square" lIns="0" tIns="0" rIns="0" bIns="0" rtlCol="0" anchor="ctr"/>
+          <a:lstStyle/>
+          <a:p>
+            <a:pPr indent="0" marL="0">
+              <a:buNone/>
+            </a:pPr>
+            <a:r>
+              <a:rPr lang="en-US" sz="1400" b="1" spc="100" kern="0" dirty="0">
+                <a:solidFill>
+                  <a:srgbClr val="5F7284"/>
+                </a:solidFill>
+                <a:latin typeface="Calibri" pitchFamily="34" charset="0"/>
+                <a:ea typeface="Calibri" pitchFamily="34" charset="-122"/>
+                <a:cs typeface="Calibri" pitchFamily="34" charset="-120"/>
+              </a:rPr>
+              <a:t>Do-ability</a:t>
+            </a:r>
+            <a:endParaRPr lang="en-US" sz="1400" dirty="0"/>
+          </a:p>
+        </p:txBody>
+      </p:sp>
+      <p:sp>
+        <p:nvSpPr>
+          <p:cNvPr id="27" name="click-4"/>
+          <p:cNvSpPr/>
+          <p:nvPr/>
+        </p:nvSpPr>
+        <p:spPr>
+          <a:xfrm>
+            <a:off x="4489704" y="3419856"/>
+            <a:ext cx="2999232" cy="548640"/>
+          </a:xfrm>
+          <a:prstGeom prst="rect">
+            <a:avLst/>
+          </a:prstGeom>
+          <a:noFill/>
+          <a:ln/>
+        </p:spPr>
+        <p:txBody>
+          <a:bodyPr wrap="square" lIns="0" tIns="0" rIns="0" bIns="0" rtlCol="0" anchor="ctr"/>
+          <a:lstStyle/>
+          <a:p>
+            <a:pPr indent="0" marL="0">
+              <a:buNone/>
+            </a:pPr>
+            <a:r>
+              <a:rPr lang="en-US" sz="2600" b="1" dirty="0">
+                <a:solidFill>
+                  <a:srgbClr val="3E9C6B"/>
+                </a:solidFill>
+                <a:latin typeface="Cambria" pitchFamily="34" charset="0"/>
+                <a:ea typeface="Cambria" pitchFamily="34" charset="-122"/>
+                <a:cs typeface="Cambria" pitchFamily="34" charset="-120"/>
+              </a:rPr>
+              <a:t>HIGH</a:t>
+            </a:r>
+            <a:endParaRPr lang="en-US" sz="2600" dirty="0"/>
+          </a:p>
+        </p:txBody>
+      </p:sp>
+      <p:sp>
+        <p:nvSpPr>
+          <p:cNvPr id="28" name="click-4"/>
+          <p:cNvSpPr/>
+          <p:nvPr/>
+        </p:nvSpPr>
+        <p:spPr>
+          <a:xfrm>
+            <a:off x="4489704" y="4041648"/>
+            <a:ext cx="2999232" cy="960120"/>
+          </a:xfrm>
+          <a:prstGeom prst="rect">
+            <a:avLst/>
+          </a:prstGeom>
+          <a:noFill/>
+          <a:ln/>
+        </p:spPr>
+        <p:txBody>
+          <a:bodyPr wrap="square" lIns="0" tIns="0" rIns="0" bIns="0" rtlCol="0" anchor="t"/>
+          <a:lstStyle/>
+          <a:p>
+            <a:pPr indent="0" marL="0">
+              <a:lnSpc>
+                <a:spcPct val="106000"/>
+              </a:lnSpc>
+              <a:buNone/>
+            </a:pPr>
+            <a:r>
+              <a:rPr lang="en-US" sz="1400" dirty="0">
+                <a:solidFill>
+                  <a:srgbClr val="1E2A36"/>
+                </a:solidFill>
+                <a:latin typeface="Calibri" pitchFamily="34" charset="0"/>
+                <a:ea typeface="Calibri" pitchFamily="34" charset="-122"/>
+                <a:cs typeface="Calibri" pitchFamily="34" charset="-120"/>
+              </a:rPr>
+              <a:t>One data source, one screen — a weekend, ~200 lines.</a:t>
+            </a:r>
+            <a:endParaRPr lang="en-US" sz="1400" dirty="0"/>
+          </a:p>
+        </p:txBody>
+      </p:sp>
+      <p:sp>
+        <p:nvSpPr>
+          <p:cNvPr id="29" name="click-4"/>
+          <p:cNvSpPr/>
+          <p:nvPr/>
+        </p:nvSpPr>
+        <p:spPr>
+          <a:xfrm>
+            <a:off x="7918704" y="2834640"/>
+            <a:ext cx="3511296" cy="2286000"/>
+          </a:xfrm>
+          <a:prstGeom prst="roundRect">
+            <a:avLst>
+              <a:gd name="adj" fmla="val 3600"/>
+            </a:avLst>
+          </a:prstGeom>
+          <a:solidFill>
+            <a:srgbClr val="FBECE8"/>
+          </a:solidFill>
+          <a:ln/>
+          <a:effectLst>
+            <a:outerShdw sx="100000" sy="100000" kx="0" ky="0" algn="bl" rotWithShape="0" blurRad="88900" dist="38100" dir="5400000">
+              <a:srgbClr val="000000">
+                <a:alpha val="13000"/>
+              </a:srgbClr>
+            </a:outerShdw>
+          </a:effectLst>
+        </p:spPr>
+      </p:sp>
+      <p:sp>
+        <p:nvSpPr>
+          <p:cNvPr id="30" name="click-4"/>
+          <p:cNvSpPr/>
+          <p:nvPr/>
+        </p:nvSpPr>
+        <p:spPr>
+          <a:xfrm>
+            <a:off x="8174736" y="3035808"/>
+            <a:ext cx="2999232" cy="402336"/>
+          </a:xfrm>
+          <a:prstGeom prst="rect">
+            <a:avLst/>
+          </a:prstGeom>
+          <a:noFill/>
+          <a:ln/>
+        </p:spPr>
+        <p:txBody>
+          <a:bodyPr wrap="square" lIns="0" tIns="0" rIns="0" bIns="0" rtlCol="0" anchor="ctr"/>
+          <a:lstStyle/>
+          <a:p>
+            <a:pPr indent="0" marL="0">
+              <a:buNone/>
+            </a:pPr>
+            <a:r>
+              <a:rPr lang="en-US" sz="1400" b="1" spc="100" kern="0" dirty="0">
+                <a:solidFill>
+                  <a:srgbClr val="5F7284"/>
+                </a:solidFill>
+                <a:latin typeface="Calibri" pitchFamily="34" charset="0"/>
+                <a:ea typeface="Calibri" pitchFamily="34" charset="-122"/>
+                <a:cs typeface="Calibri" pitchFamily="34" charset="-120"/>
+              </a:rPr>
+              <a:t>Richness</a:t>
+            </a:r>
+            <a:endParaRPr lang="en-US" sz="1400" dirty="0"/>
+          </a:p>
+        </p:txBody>
+      </p:sp>
+      <p:sp>
+        <p:nvSpPr>
+          <p:cNvPr id="31" name="click-4"/>
+          <p:cNvSpPr/>
+          <p:nvPr/>
+        </p:nvSpPr>
+        <p:spPr>
+          <a:xfrm>
+            <a:off x="8174736" y="3419856"/>
+            <a:ext cx="2999232" cy="548640"/>
+          </a:xfrm>
+          <a:prstGeom prst="rect">
+            <a:avLst/>
+          </a:prstGeom>
+          <a:noFill/>
+          <a:ln/>
+        </p:spPr>
+        <p:txBody>
+          <a:bodyPr wrap="square" lIns="0" tIns="0" rIns="0" bIns="0" rtlCol="0" anchor="ctr"/>
+          <a:lstStyle/>
+          <a:p>
+            <a:pPr indent="0" marL="0">
+              <a:buNone/>
+            </a:pPr>
+            <a:r>
+              <a:rPr lang="en-US" sz="2600" b="1" dirty="0">
+                <a:solidFill>
+                  <a:srgbClr val="D9614C"/>
+                </a:solidFill>
+                <a:latin typeface="Cambria" pitchFamily="34" charset="0"/>
+                <a:ea typeface="Cambria" pitchFamily="34" charset="-122"/>
+                <a:cs typeface="Cambria" pitchFamily="34" charset="-120"/>
+              </a:rPr>
+              <a:t>FAILS</a:t>
+            </a:r>
+            <a:endParaRPr lang="en-US" sz="2600" dirty="0"/>
+          </a:p>
+        </p:txBody>
+      </p:sp>
+      <p:sp>
+        <p:nvSpPr>
+          <p:cNvPr id="32" name="click-4"/>
+          <p:cNvSpPr/>
+          <p:nvPr/>
+        </p:nvSpPr>
+        <p:spPr>
+          <a:xfrm>
+            <a:off x="8174736" y="4041648"/>
+            <a:ext cx="2999232" cy="960120"/>
+          </a:xfrm>
+          <a:prstGeom prst="rect">
+            <a:avLst/>
+          </a:prstGeom>
+          <a:noFill/>
+          <a:ln/>
+        </p:spPr>
+        <p:txBody>
+          <a:bodyPr wrap="square" lIns="0" tIns="0" rIns="0" bIns="0" rtlCol="0" anchor="t"/>
+          <a:lstStyle/>
+          <a:p>
+            <a:pPr indent="0" marL="0">
+              <a:lnSpc>
+                <a:spcPct val="106000"/>
+              </a:lnSpc>
+              <a:buNone/>
+            </a:pPr>
+            <a:r>
+              <a:rPr lang="en-US" sz="1400" dirty="0">
+                <a:solidFill>
+                  <a:srgbClr val="1E2A36"/>
+                </a:solidFill>
+                <a:latin typeface="Calibri" pitchFamily="34" charset="0"/>
+                <a:ea typeface="Calibri" pitchFamily="34" charset="-122"/>
+                <a:cs typeface="Calibri" pitchFamily="34" charset="-120"/>
+              </a:rPr>
+              <a:t>One component. Finish it and there's nothing left to found.</a:t>
+            </a:r>
+            <a:endParaRPr lang="en-US" sz="1400" dirty="0"/>
+          </a:p>
+        </p:txBody>
+      </p:sp>
+      <p:sp>
+        <p:nvSpPr>
+          <p:cNvPr id="33" name="click-5"/>
+          <p:cNvSpPr/>
+          <p:nvPr/>
+        </p:nvSpPr>
+        <p:spPr>
+          <a:xfrm>
+            <a:off x="548640" y="5349240"/>
+            <a:ext cx="11064240" cy="822960"/>
+          </a:xfrm>
+          <a:prstGeom prst="roundRect">
+            <a:avLst>
+              <a:gd name="adj" fmla="val 10000"/>
+            </a:avLst>
+          </a:prstGeom>
+          <a:solidFill>
+            <a:srgbClr val="14233A"/>
+          </a:solidFill>
+          <a:ln/>
+          <a:effectLst>
+            <a:outerShdw sx="100000" sy="100000" kx="0" ky="0" algn="bl" rotWithShape="0" blurRad="88900" dist="38100" dir="5400000">
+              <a:srgbClr val="000000">
+                <a:alpha val="13000"/>
+              </a:srgbClr>
+            </a:outerShdw>
+          </a:effectLst>
+        </p:spPr>
+      </p:sp>
+      <p:sp>
+        <p:nvSpPr>
+          <p:cNvPr id="34" name="click-5"/>
           <p:cNvSpPr/>
           <p:nvPr/>
         </p:nvSpPr>
@@ -17246,7 +17693,7 @@
       </p:sp>
       <p:pic>
         <p:nvPicPr>
-          <p:cNvPr id="23" name="Image 1" descr="preencoded.png">    </p:cNvPr>
+          <p:cNvPr id="35" name="click-5" descr="preencoded.png">    </p:cNvPr>
           <p:cNvPicPr>
             <a:picLocks noChangeAspect="1"/>
           </p:cNvPicPr>
@@ -17270,7 +17717,7 @@
       </p:pic>
       <p:sp>
         <p:nvSpPr>
-          <p:cNvPr id="24" name="Text 20"/>
+          <p:cNvPr id="36" name="click-5"/>
           <p:cNvSpPr/>
           <p:nvPr/>
         </p:nvSpPr>
@@ -17323,7 +17770,7 @@
       </p:sp>
       <p:sp>
         <p:nvSpPr>
-          <p:cNvPr id="25" name="Text 21"/>
+          <p:cNvPr id="37" name="Text 33"/>
           <p:cNvSpPr/>
           <p:nvPr/>
         </p:nvSpPr>
@@ -17362,7 +17809,7 @@
       </p:sp>
       <p:sp>
         <p:nvSpPr>
-          <p:cNvPr id="26" name="Text 22"/>
+          <p:cNvPr id="38" name="Text 34"/>
           <p:cNvSpPr/>
           <p:nvPr/>
         </p:nvSpPr>
@@ -17404,6 +17851,743 @@
   <p:clrMapOvr>
     <a:masterClrMapping/>
   </p:clrMapOvr>
+  <p:timing>
+    <p:tnLst>
+      <p:par>
+        <p:cTn id="1" dur="indefinite" restart="never" nodeType="tmRoot">
+          <p:childTnLst>
+            <p:seq concurrent="1" nextAc="seek">
+              <p:cTn id="2" dur="indefinite" nodeType="mainSeq">
+                <p:childTnLst>
+                  <p:par>
+                    <p:cTn id="3" fill="hold">
+                      <p:stCondLst>
+                        <p:cond delay="indefinite"/>
+                      </p:stCondLst>
+                      <p:childTnLst>
+                        <p:par>
+                          <p:cTn id="4" fill="hold">
+                            <p:stCondLst>
+                              <p:cond delay="0"/>
+                            </p:stCondLst>
+                            <p:childTnLst>
+                              <p:par>
+                                <p:cTn id="6" presetID="1" presetClass="entr" presetSubtype="0" fill="hold" grpId="0" nodeType="clickEffect">
+                                  <p:stCondLst>
+                                    <p:cond delay="0"/>
+                                  </p:stCondLst>
+                                  <p:childTnLst>
+                                    <p:set>
+                                      <p:cBhvr>
+                                        <p:cTn id="5" dur="1" fill="hold">
+                                          <p:stCondLst>
+                                            <p:cond delay="0"/>
+                                          </p:stCondLst>
+                                        </p:cTn>
+                                        <p:tgtEl>
+                                          <p:spTgt spid="11"/>
+                                        </p:tgtEl>
+                                        <p:attrNameLst>
+                                          <p:attrName>style.visibility</p:attrName>
+                                        </p:attrNameLst>
+                                      </p:cBhvr>
+                                      <p:to>
+                                        <p:strVal val="visible"/>
+                                      </p:to>
+                                    </p:set>
+                                  </p:childTnLst>
+                                </p:cTn>
+                              </p:par>
+                              <p:par>
+                                <p:cTn id="8" presetID="1" presetClass="entr" presetSubtype="0" fill="hold" grpId="0" nodeType="withEffect">
+                                  <p:stCondLst>
+                                    <p:cond delay="0"/>
+                                  </p:stCondLst>
+                                  <p:childTnLst>
+                                    <p:set>
+                                      <p:cBhvr>
+                                        <p:cTn id="7" dur="1" fill="hold">
+                                          <p:stCondLst>
+                                            <p:cond delay="0"/>
+                                          </p:stCondLst>
+                                        </p:cTn>
+                                        <p:tgtEl>
+                                          <p:spTgt spid="12"/>
+                                        </p:tgtEl>
+                                        <p:attrNameLst>
+                                          <p:attrName>style.visibility</p:attrName>
+                                        </p:attrNameLst>
+                                      </p:cBhvr>
+                                      <p:to>
+                                        <p:strVal val="visible"/>
+                                      </p:to>
+                                    </p:set>
+                                  </p:childTnLst>
+                                </p:cTn>
+                              </p:par>
+                            </p:childTnLst>
+                          </p:cTn>
+                        </p:par>
+                      </p:childTnLst>
+                    </p:cTn>
+                  </p:par>
+                  <p:par>
+                    <p:cTn id="9" fill="hold">
+                      <p:stCondLst>
+                        <p:cond delay="indefinite"/>
+                      </p:stCondLst>
+                      <p:childTnLst>
+                        <p:par>
+                          <p:cTn id="10" fill="hold">
+                            <p:stCondLst>
+                              <p:cond delay="0"/>
+                            </p:stCondLst>
+                            <p:childTnLst>
+                              <p:par>
+                                <p:cTn id="12" presetID="1" presetClass="entr" presetSubtype="0" fill="hold" grpId="0" nodeType="clickEffect">
+                                  <p:stCondLst>
+                                    <p:cond delay="0"/>
+                                  </p:stCondLst>
+                                  <p:childTnLst>
+                                    <p:set>
+                                      <p:cBhvr>
+                                        <p:cTn id="11" dur="1" fill="hold">
+                                          <p:stCondLst>
+                                            <p:cond delay="0"/>
+                                          </p:stCondLst>
+                                        </p:cTn>
+                                        <p:tgtEl>
+                                          <p:spTgt spid="15"/>
+                                        </p:tgtEl>
+                                        <p:attrNameLst>
+                                          <p:attrName>style.visibility</p:attrName>
+                                        </p:attrNameLst>
+                                      </p:cBhvr>
+                                      <p:to>
+                                        <p:strVal val="visible"/>
+                                      </p:to>
+                                    </p:set>
+                                  </p:childTnLst>
+                                </p:cTn>
+                              </p:par>
+                              <p:par>
+                                <p:cTn id="14" presetID="1" presetClass="entr" presetSubtype="0" fill="hold" grpId="0" nodeType="withEffect">
+                                  <p:stCondLst>
+                                    <p:cond delay="0"/>
+                                  </p:stCondLst>
+                                  <p:childTnLst>
+                                    <p:set>
+                                      <p:cBhvr>
+                                        <p:cTn id="13" dur="1" fill="hold">
+                                          <p:stCondLst>
+                                            <p:cond delay="0"/>
+                                          </p:stCondLst>
+                                        </p:cTn>
+                                        <p:tgtEl>
+                                          <p:spTgt spid="16"/>
+                                        </p:tgtEl>
+                                        <p:attrNameLst>
+                                          <p:attrName>style.visibility</p:attrName>
+                                        </p:attrNameLst>
+                                      </p:cBhvr>
+                                      <p:to>
+                                        <p:strVal val="visible"/>
+                                      </p:to>
+                                    </p:set>
+                                  </p:childTnLst>
+                                </p:cTn>
+                              </p:par>
+                            </p:childTnLst>
+                          </p:cTn>
+                        </p:par>
+                      </p:childTnLst>
+                    </p:cTn>
+                  </p:par>
+                  <p:par>
+                    <p:cTn id="15" fill="hold">
+                      <p:stCondLst>
+                        <p:cond delay="indefinite"/>
+                      </p:stCondLst>
+                      <p:childTnLst>
+                        <p:par>
+                          <p:cTn id="16" fill="hold">
+                            <p:stCondLst>
+                              <p:cond delay="0"/>
+                            </p:stCondLst>
+                            <p:childTnLst>
+                              <p:par>
+                                <p:cTn id="18" presetID="1" presetClass="entr" presetSubtype="0" fill="hold" grpId="0" nodeType="clickEffect">
+                                  <p:stCondLst>
+                                    <p:cond delay="0"/>
+                                  </p:stCondLst>
+                                  <p:childTnLst>
+                                    <p:set>
+                                      <p:cBhvr>
+                                        <p:cTn id="17" dur="1" fill="hold">
+                                          <p:stCondLst>
+                                            <p:cond delay="0"/>
+                                          </p:stCondLst>
+                                        </p:cTn>
+                                        <p:tgtEl>
+                                          <p:spTgt spid="19"/>
+                                        </p:tgtEl>
+                                        <p:attrNameLst>
+                                          <p:attrName>style.visibility</p:attrName>
+                                        </p:attrNameLst>
+                                      </p:cBhvr>
+                                      <p:to>
+                                        <p:strVal val="visible"/>
+                                      </p:to>
+                                    </p:set>
+                                  </p:childTnLst>
+                                </p:cTn>
+                              </p:par>
+                              <p:par>
+                                <p:cTn id="20" presetID="1" presetClass="entr" presetSubtype="0" fill="hold" grpId="0" nodeType="withEffect">
+                                  <p:stCondLst>
+                                    <p:cond delay="0"/>
+                                  </p:stCondLst>
+                                  <p:childTnLst>
+                                    <p:set>
+                                      <p:cBhvr>
+                                        <p:cTn id="19" dur="1" fill="hold">
+                                          <p:stCondLst>
+                                            <p:cond delay="0"/>
+                                          </p:stCondLst>
+                                        </p:cTn>
+                                        <p:tgtEl>
+                                          <p:spTgt spid="20"/>
+                                        </p:tgtEl>
+                                        <p:attrNameLst>
+                                          <p:attrName>style.visibility</p:attrName>
+                                        </p:attrNameLst>
+                                      </p:cBhvr>
+                                      <p:to>
+                                        <p:strVal val="visible"/>
+                                      </p:to>
+                                    </p:set>
+                                  </p:childTnLst>
+                                </p:cTn>
+                              </p:par>
+                            </p:childTnLst>
+                          </p:cTn>
+                        </p:par>
+                      </p:childTnLst>
+                    </p:cTn>
+                  </p:par>
+                  <p:par>
+                    <p:cTn id="21" fill="hold">
+                      <p:stCondLst>
+                        <p:cond delay="indefinite"/>
+                      </p:stCondLst>
+                      <p:childTnLst>
+                        <p:par>
+                          <p:cTn id="22" fill="hold">
+                            <p:stCondLst>
+                              <p:cond delay="0"/>
+                            </p:stCondLst>
+                            <p:childTnLst>
+                              <p:par>
+                                <p:cTn id="24" presetID="1" presetClass="entr" presetSubtype="0" fill="hold" grpId="0" nodeType="clickEffect">
+                                  <p:stCondLst>
+                                    <p:cond delay="0"/>
+                                  </p:stCondLst>
+                                  <p:childTnLst>
+                                    <p:set>
+                                      <p:cBhvr>
+                                        <p:cTn id="23" dur="1" fill="hold">
+                                          <p:stCondLst>
+                                            <p:cond delay="0"/>
+                                          </p:stCondLst>
+                                        </p:cTn>
+                                        <p:tgtEl>
+                                          <p:spTgt spid="21"/>
+                                        </p:tgtEl>
+                                        <p:attrNameLst>
+                                          <p:attrName>style.visibility</p:attrName>
+                                        </p:attrNameLst>
+                                      </p:cBhvr>
+                                      <p:to>
+                                        <p:strVal val="visible"/>
+                                      </p:to>
+                                    </p:set>
+                                  </p:childTnLst>
+                                </p:cTn>
+                              </p:par>
+                              <p:par>
+                                <p:cTn id="26" presetID="1" presetClass="entr" presetSubtype="0" fill="hold" grpId="0" nodeType="withEffect">
+                                  <p:stCondLst>
+                                    <p:cond delay="0"/>
+                                  </p:stCondLst>
+                                  <p:childTnLst>
+                                    <p:set>
+                                      <p:cBhvr>
+                                        <p:cTn id="25" dur="1" fill="hold">
+                                          <p:stCondLst>
+                                            <p:cond delay="0"/>
+                                          </p:stCondLst>
+                                        </p:cTn>
+                                        <p:tgtEl>
+                                          <p:spTgt spid="22"/>
+                                        </p:tgtEl>
+                                        <p:attrNameLst>
+                                          <p:attrName>style.visibility</p:attrName>
+                                        </p:attrNameLst>
+                                      </p:cBhvr>
+                                      <p:to>
+                                        <p:strVal val="visible"/>
+                                      </p:to>
+                                    </p:set>
+                                  </p:childTnLst>
+                                </p:cTn>
+                              </p:par>
+                              <p:par>
+                                <p:cTn id="28" presetID="1" presetClass="entr" presetSubtype="0" fill="hold" grpId="0" nodeType="withEffect">
+                                  <p:stCondLst>
+                                    <p:cond delay="0"/>
+                                  </p:stCondLst>
+                                  <p:childTnLst>
+                                    <p:set>
+                                      <p:cBhvr>
+                                        <p:cTn id="27" dur="1" fill="hold">
+                                          <p:stCondLst>
+                                            <p:cond delay="0"/>
+                                          </p:stCondLst>
+                                        </p:cTn>
+                                        <p:tgtEl>
+                                          <p:spTgt spid="23"/>
+                                        </p:tgtEl>
+                                        <p:attrNameLst>
+                                          <p:attrName>style.visibility</p:attrName>
+                                        </p:attrNameLst>
+                                      </p:cBhvr>
+                                      <p:to>
+                                        <p:strVal val="visible"/>
+                                      </p:to>
+                                    </p:set>
+                                  </p:childTnLst>
+                                </p:cTn>
+                              </p:par>
+                              <p:par>
+                                <p:cTn id="30" presetID="1" presetClass="entr" presetSubtype="0" fill="hold" grpId="0" nodeType="withEffect">
+                                  <p:stCondLst>
+                                    <p:cond delay="0"/>
+                                  </p:stCondLst>
+                                  <p:childTnLst>
+                                    <p:set>
+                                      <p:cBhvr>
+                                        <p:cTn id="29" dur="1" fill="hold">
+                                          <p:stCondLst>
+                                            <p:cond delay="0"/>
+                                          </p:stCondLst>
+                                        </p:cTn>
+                                        <p:tgtEl>
+                                          <p:spTgt spid="24"/>
+                                        </p:tgtEl>
+                                        <p:attrNameLst>
+                                          <p:attrName>style.visibility</p:attrName>
+                                        </p:attrNameLst>
+                                      </p:cBhvr>
+                                      <p:to>
+                                        <p:strVal val="visible"/>
+                                      </p:to>
+                                    </p:set>
+                                  </p:childTnLst>
+                                </p:cTn>
+                              </p:par>
+                              <p:par>
+                                <p:cTn id="32" presetID="1" presetClass="entr" presetSubtype="0" fill="hold" grpId="0" nodeType="withEffect">
+                                  <p:stCondLst>
+                                    <p:cond delay="0"/>
+                                  </p:stCondLst>
+                                  <p:childTnLst>
+                                    <p:set>
+                                      <p:cBhvr>
+                                        <p:cTn id="31" dur="1" fill="hold">
+                                          <p:stCondLst>
+                                            <p:cond delay="0"/>
+                                          </p:stCondLst>
+                                        </p:cTn>
+                                        <p:tgtEl>
+                                          <p:spTgt spid="25"/>
+                                        </p:tgtEl>
+                                        <p:attrNameLst>
+                                          <p:attrName>style.visibility</p:attrName>
+                                        </p:attrNameLst>
+                                      </p:cBhvr>
+                                      <p:to>
+                                        <p:strVal val="visible"/>
+                                      </p:to>
+                                    </p:set>
+                                  </p:childTnLst>
+                                </p:cTn>
+                              </p:par>
+                              <p:par>
+                                <p:cTn id="34" presetID="1" presetClass="entr" presetSubtype="0" fill="hold" grpId="0" nodeType="withEffect">
+                                  <p:stCondLst>
+                                    <p:cond delay="0"/>
+                                  </p:stCondLst>
+                                  <p:childTnLst>
+                                    <p:set>
+                                      <p:cBhvr>
+                                        <p:cTn id="33" dur="1" fill="hold">
+                                          <p:stCondLst>
+                                            <p:cond delay="0"/>
+                                          </p:stCondLst>
+                                        </p:cTn>
+                                        <p:tgtEl>
+                                          <p:spTgt spid="26"/>
+                                        </p:tgtEl>
+                                        <p:attrNameLst>
+                                          <p:attrName>style.visibility</p:attrName>
+                                        </p:attrNameLst>
+                                      </p:cBhvr>
+                                      <p:to>
+                                        <p:strVal val="visible"/>
+                                      </p:to>
+                                    </p:set>
+                                  </p:childTnLst>
+                                </p:cTn>
+                              </p:par>
+                              <p:par>
+                                <p:cTn id="36" presetID="1" presetClass="entr" presetSubtype="0" fill="hold" grpId="0" nodeType="withEffect">
+                                  <p:stCondLst>
+                                    <p:cond delay="0"/>
+                                  </p:stCondLst>
+                                  <p:childTnLst>
+                                    <p:set>
+                                      <p:cBhvr>
+                                        <p:cTn id="35" dur="1" fill="hold">
+                                          <p:stCondLst>
+                                            <p:cond delay="0"/>
+                                          </p:stCondLst>
+                                        </p:cTn>
+                                        <p:tgtEl>
+                                          <p:spTgt spid="27"/>
+                                        </p:tgtEl>
+                                        <p:attrNameLst>
+                                          <p:attrName>style.visibility</p:attrName>
+                                        </p:attrNameLst>
+                                      </p:cBhvr>
+                                      <p:to>
+                                        <p:strVal val="visible"/>
+                                      </p:to>
+                                    </p:set>
+                                  </p:childTnLst>
+                                </p:cTn>
+                              </p:par>
+                              <p:par>
+                                <p:cTn id="38" presetID="1" presetClass="entr" presetSubtype="0" fill="hold" grpId="0" nodeType="withEffect">
+                                  <p:stCondLst>
+                                    <p:cond delay="0"/>
+                                  </p:stCondLst>
+                                  <p:childTnLst>
+                                    <p:set>
+                                      <p:cBhvr>
+                                        <p:cTn id="37" dur="1" fill="hold">
+                                          <p:stCondLst>
+                                            <p:cond delay="0"/>
+                                          </p:stCondLst>
+                                        </p:cTn>
+                                        <p:tgtEl>
+                                          <p:spTgt spid="28"/>
+                                        </p:tgtEl>
+                                        <p:attrNameLst>
+                                          <p:attrName>style.visibility</p:attrName>
+                                        </p:attrNameLst>
+                                      </p:cBhvr>
+                                      <p:to>
+                                        <p:strVal val="visible"/>
+                                      </p:to>
+                                    </p:set>
+                                  </p:childTnLst>
+                                </p:cTn>
+                              </p:par>
+                              <p:par>
+                                <p:cTn id="40" presetID="1" presetClass="entr" presetSubtype="0" fill="hold" grpId="0" nodeType="withEffect">
+                                  <p:stCondLst>
+                                    <p:cond delay="0"/>
+                                  </p:stCondLst>
+                                  <p:childTnLst>
+                                    <p:set>
+                                      <p:cBhvr>
+                                        <p:cTn id="39" dur="1" fill="hold">
+                                          <p:stCondLst>
+                                            <p:cond delay="0"/>
+                                          </p:stCondLst>
+                                        </p:cTn>
+                                        <p:tgtEl>
+                                          <p:spTgt spid="29"/>
+                                        </p:tgtEl>
+                                        <p:attrNameLst>
+                                          <p:attrName>style.visibility</p:attrName>
+                                        </p:attrNameLst>
+                                      </p:cBhvr>
+                                      <p:to>
+                                        <p:strVal val="visible"/>
+                                      </p:to>
+                                    </p:set>
+                                  </p:childTnLst>
+                                </p:cTn>
+                              </p:par>
+                              <p:par>
+                                <p:cTn id="42" presetID="1" presetClass="entr" presetSubtype="0" fill="hold" grpId="0" nodeType="withEffect">
+                                  <p:stCondLst>
+                                    <p:cond delay="0"/>
+                                  </p:stCondLst>
+                                  <p:childTnLst>
+                                    <p:set>
+                                      <p:cBhvr>
+                                        <p:cTn id="41" dur="1" fill="hold">
+                                          <p:stCondLst>
+                                            <p:cond delay="0"/>
+                                          </p:stCondLst>
+                                        </p:cTn>
+                                        <p:tgtEl>
+                                          <p:spTgt spid="30"/>
+                                        </p:tgtEl>
+                                        <p:attrNameLst>
+                                          <p:attrName>style.visibility</p:attrName>
+                                        </p:attrNameLst>
+                                      </p:cBhvr>
+                                      <p:to>
+                                        <p:strVal val="visible"/>
+                                      </p:to>
+                                    </p:set>
+                                  </p:childTnLst>
+                                </p:cTn>
+                              </p:par>
+                              <p:par>
+                                <p:cTn id="44" presetID="1" presetClass="entr" presetSubtype="0" fill="hold" grpId="0" nodeType="withEffect">
+                                  <p:stCondLst>
+                                    <p:cond delay="0"/>
+                                  </p:stCondLst>
+                                  <p:childTnLst>
+                                    <p:set>
+                                      <p:cBhvr>
+                                        <p:cTn id="43" dur="1" fill="hold">
+                                          <p:stCondLst>
+                                            <p:cond delay="0"/>
+                                          </p:stCondLst>
+                                        </p:cTn>
+                                        <p:tgtEl>
+                                          <p:spTgt spid="31"/>
+                                        </p:tgtEl>
+                                        <p:attrNameLst>
+                                          <p:attrName>style.visibility</p:attrName>
+                                        </p:attrNameLst>
+                                      </p:cBhvr>
+                                      <p:to>
+                                        <p:strVal val="visible"/>
+                                      </p:to>
+                                    </p:set>
+                                  </p:childTnLst>
+                                </p:cTn>
+                              </p:par>
+                              <p:par>
+                                <p:cTn id="46" presetID="1" presetClass="entr" presetSubtype="0" fill="hold" grpId="0" nodeType="withEffect">
+                                  <p:stCondLst>
+                                    <p:cond delay="0"/>
+                                  </p:stCondLst>
+                                  <p:childTnLst>
+                                    <p:set>
+                                      <p:cBhvr>
+                                        <p:cTn id="45" dur="1" fill="hold">
+                                          <p:stCondLst>
+                                            <p:cond delay="0"/>
+                                          </p:stCondLst>
+                                        </p:cTn>
+                                        <p:tgtEl>
+                                          <p:spTgt spid="32"/>
+                                        </p:tgtEl>
+                                        <p:attrNameLst>
+                                          <p:attrName>style.visibility</p:attrName>
+                                        </p:attrNameLst>
+                                      </p:cBhvr>
+                                      <p:to>
+                                        <p:strVal val="visible"/>
+                                      </p:to>
+                                    </p:set>
+                                  </p:childTnLst>
+                                </p:cTn>
+                              </p:par>
+                            </p:childTnLst>
+                          </p:cTn>
+                        </p:par>
+                      </p:childTnLst>
+                    </p:cTn>
+                  </p:par>
+                  <p:par>
+                    <p:cTn id="47" fill="hold">
+                      <p:stCondLst>
+                        <p:cond delay="indefinite"/>
+                      </p:stCondLst>
+                      <p:childTnLst>
+                        <p:par>
+                          <p:cTn id="48" fill="hold">
+                            <p:stCondLst>
+                              <p:cond delay="0"/>
+                            </p:stCondLst>
+                            <p:childTnLst>
+                              <p:par>
+                                <p:cTn id="50" presetID="1" presetClass="entr" presetSubtype="0" fill="hold" grpId="0" nodeType="clickEffect">
+                                  <p:stCondLst>
+                                    <p:cond delay="0"/>
+                                  </p:stCondLst>
+                                  <p:childTnLst>
+                                    <p:set>
+                                      <p:cBhvr>
+                                        <p:cTn id="49" dur="1" fill="hold">
+                                          <p:stCondLst>
+                                            <p:cond delay="0"/>
+                                          </p:stCondLst>
+                                        </p:cTn>
+                                        <p:tgtEl>
+                                          <p:spTgt spid="33"/>
+                                        </p:tgtEl>
+                                        <p:attrNameLst>
+                                          <p:attrName>style.visibility</p:attrName>
+                                        </p:attrNameLst>
+                                      </p:cBhvr>
+                                      <p:to>
+                                        <p:strVal val="visible"/>
+                                      </p:to>
+                                    </p:set>
+                                  </p:childTnLst>
+                                </p:cTn>
+                              </p:par>
+                              <p:par>
+                                <p:cTn id="52" presetID="1" presetClass="entr" presetSubtype="0" fill="hold" grpId="0" nodeType="withEffect">
+                                  <p:stCondLst>
+                                    <p:cond delay="0"/>
+                                  </p:stCondLst>
+                                  <p:childTnLst>
+                                    <p:set>
+                                      <p:cBhvr>
+                                        <p:cTn id="51" dur="1" fill="hold">
+                                          <p:stCondLst>
+                                            <p:cond delay="0"/>
+                                          </p:stCondLst>
+                                        </p:cTn>
+                                        <p:tgtEl>
+                                          <p:spTgt spid="34"/>
+                                        </p:tgtEl>
+                                        <p:attrNameLst>
+                                          <p:attrName>style.visibility</p:attrName>
+                                        </p:attrNameLst>
+                                      </p:cBhvr>
+                                      <p:to>
+                                        <p:strVal val="visible"/>
+                                      </p:to>
+                                    </p:set>
+                                  </p:childTnLst>
+                                </p:cTn>
+                              </p:par>
+                              <p:par>
+                                <p:cTn id="54" presetID="1" presetClass="entr" presetSubtype="0" fill="hold" nodeType="withEffect">
+                                  <p:stCondLst>
+                                    <p:cond delay="0"/>
+                                  </p:stCondLst>
+                                  <p:childTnLst>
+                                    <p:set>
+                                      <p:cBhvr>
+                                        <p:cTn id="53" dur="1" fill="hold">
+                                          <p:stCondLst>
+                                            <p:cond delay="0"/>
+                                          </p:stCondLst>
+                                        </p:cTn>
+                                        <p:tgtEl>
+                                          <p:spTgt spid="35"/>
+                                        </p:tgtEl>
+                                        <p:attrNameLst>
+                                          <p:attrName>style.visibility</p:attrName>
+                                        </p:attrNameLst>
+                                      </p:cBhvr>
+                                      <p:to>
+                                        <p:strVal val="visible"/>
+                                      </p:to>
+                                    </p:set>
+                                  </p:childTnLst>
+                                </p:cTn>
+                              </p:par>
+                              <p:par>
+                                <p:cTn id="56" presetID="1" presetClass="entr" presetSubtype="0" fill="hold" grpId="0" nodeType="withEffect">
+                                  <p:stCondLst>
+                                    <p:cond delay="0"/>
+                                  </p:stCondLst>
+                                  <p:childTnLst>
+                                    <p:set>
+                                      <p:cBhvr>
+                                        <p:cTn id="55" dur="1" fill="hold">
+                                          <p:stCondLst>
+                                            <p:cond delay="0"/>
+                                          </p:stCondLst>
+                                        </p:cTn>
+                                        <p:tgtEl>
+                                          <p:spTgt spid="36"/>
+                                        </p:tgtEl>
+                                        <p:attrNameLst>
+                                          <p:attrName>style.visibility</p:attrName>
+                                        </p:attrNameLst>
+                                      </p:cBhvr>
+                                      <p:to>
+                                        <p:strVal val="visible"/>
+                                      </p:to>
+                                    </p:set>
+                                  </p:childTnLst>
+                                </p:cTn>
+                              </p:par>
+                            </p:childTnLst>
+                          </p:cTn>
+                        </p:par>
+                      </p:childTnLst>
+                    </p:cTn>
+                  </p:par>
+                </p:childTnLst>
+              </p:cTn>
+              <p:prevCondLst>
+                <p:cond evt="onPrev" delay="0">
+                  <p:tgtEl>
+                    <p:sldTgt/>
+                  </p:tgtEl>
+                </p:cond>
+              </p:prevCondLst>
+              <p:nextCondLst>
+                <p:cond evt="onNext" delay="0">
+                  <p:tgtEl>
+                    <p:sldTgt/>
+                  </p:tgtEl>
+                </p:cond>
+              </p:nextCondLst>
+            </p:seq>
+          </p:childTnLst>
+        </p:cTn>
+      </p:par>
+    </p:tnLst>
+    <p:bldLst>
+      <p:bldP spid="11" grpId="0" animBg="1"/>
+      <p:bldP spid="12" grpId="0" animBg="1"/>
+      <p:bldP spid="15" grpId="0" animBg="1"/>
+      <p:bldP spid="16" grpId="0" animBg="1"/>
+      <p:bldP spid="19" grpId="0" animBg="1"/>
+      <p:bldP spid="20" grpId="0" animBg="1"/>
+      <p:bldP spid="21" grpId="0" animBg="1"/>
+      <p:bldP spid="22" grpId="0" animBg="1"/>
+      <p:bldP spid="23" grpId="0" animBg="1"/>
+      <p:bldP spid="24" grpId="0" animBg="1"/>
+      <p:bldP spid="25" grpId="0" animBg="1"/>
+      <p:bldP spid="26" grpId="0" animBg="1"/>
+      <p:bldP spid="27" grpId="0" animBg="1"/>
+      <p:bldP spid="28" grpId="0" animBg="1"/>
+      <p:bldP spid="29" grpId="0" animBg="1"/>
+      <p:bldP spid="30" grpId="0" animBg="1"/>
+      <p:bldP spid="31" grpId="0" animBg="1"/>
+      <p:bldP spid="32" grpId="0" animBg="1"/>
+      <p:bldP spid="33" grpId="0" animBg="1"/>
+      <p:bldP spid="34" grpId="0" animBg="1"/>
+      <p:bldP spid="36" grpId="0" animBg="1"/>
+    </p:bldLst>
+  </p:timing>
 </p:sld>
 </file>
 
@@ -17523,7 +18707,7 @@
                 <a:ea typeface="Cambria" pitchFamily="34" charset="-122"/>
                 <a:cs typeface="Cambria" pitchFamily="34" charset="-120"/>
               </a:rPr>
-              <a:t>CrowdDefense — rich, but scary</a:t>
+              <a:t>CrowdDefense</a:t>
             </a:r>
             <a:endParaRPr lang="en-US" sz="3100" dirty="0"/>
           </a:p>
@@ -17985,7 +19169,7 @@
       </p:sp>
       <p:sp>
         <p:nvSpPr>
-          <p:cNvPr id="16" name="Text 13"/>
+          <p:cNvPr id="16" name="click-1"/>
           <p:cNvSpPr/>
           <p:nvPr/>
         </p:nvSpPr>
@@ -18092,7 +19276,7 @@
       </p:sp>
       <p:sp>
         <p:nvSpPr>
-          <p:cNvPr id="19" name="Text 16"/>
+          <p:cNvPr id="19" name="click-2"/>
           <p:cNvSpPr/>
           <p:nvPr/>
         </p:nvSpPr>
@@ -18199,7 +19383,7 @@
       </p:sp>
       <p:sp>
         <p:nvSpPr>
-          <p:cNvPr id="22" name="Text 19"/>
+          <p:cNvPr id="22" name="click-3"/>
           <p:cNvSpPr/>
           <p:nvPr/>
         </p:nvSpPr>
@@ -18238,7 +19422,7 @@
       </p:sp>
       <p:sp>
         <p:nvSpPr>
-          <p:cNvPr id="23" name="Shape 20"/>
+          <p:cNvPr id="23" name="click-4"/>
           <p:cNvSpPr/>
           <p:nvPr/>
         </p:nvSpPr>
@@ -18267,7 +19451,7 @@
       </p:sp>
       <p:sp>
         <p:nvSpPr>
-          <p:cNvPr id="24" name="Shape 21"/>
+          <p:cNvPr id="24" name="click-4"/>
           <p:cNvSpPr/>
           <p:nvPr/>
         </p:nvSpPr>
@@ -18287,7 +19471,7 @@
       </p:sp>
       <p:pic>
         <p:nvPicPr>
-          <p:cNvPr id="25" name="Image 1" descr="preencoded.png">    </p:cNvPr>
+          <p:cNvPr id="25" name="click-4" descr="preencoded.png">    </p:cNvPr>
           <p:cNvPicPr>
             <a:picLocks noChangeAspect="1"/>
           </p:cNvPicPr>
@@ -18311,7 +19495,7 @@
       </p:pic>
       <p:sp>
         <p:nvSpPr>
-          <p:cNvPr id="26" name="Text 22"/>
+          <p:cNvPr id="26" name="click-4"/>
           <p:cNvSpPr/>
           <p:nvPr/>
         </p:nvSpPr>
@@ -18445,6 +19629,305 @@
   <p:clrMapOvr>
     <a:masterClrMapping/>
   </p:clrMapOvr>
+  <p:timing>
+    <p:tnLst>
+      <p:par>
+        <p:cTn id="1" dur="indefinite" restart="never" nodeType="tmRoot">
+          <p:childTnLst>
+            <p:seq concurrent="1" nextAc="seek">
+              <p:cTn id="2" dur="indefinite" nodeType="mainSeq">
+                <p:childTnLst>
+                  <p:par>
+                    <p:cTn id="3" fill="hold">
+                      <p:stCondLst>
+                        <p:cond delay="indefinite"/>
+                      </p:stCondLst>
+                      <p:childTnLst>
+                        <p:par>
+                          <p:cTn id="4" fill="hold">
+                            <p:stCondLst>
+                              <p:cond delay="0"/>
+                            </p:stCondLst>
+                            <p:childTnLst>
+                              <p:par>
+                                <p:cTn id="6" presetID="1" presetClass="entr" presetSubtype="0" fill="hold" grpId="0" nodeType="clickEffect">
+                                  <p:stCondLst>
+                                    <p:cond delay="0"/>
+                                  </p:stCondLst>
+                                  <p:childTnLst>
+                                    <p:set>
+                                      <p:cBhvr>
+                                        <p:cTn id="5" dur="1" fill="hold">
+                                          <p:stCondLst>
+                                            <p:cond delay="0"/>
+                                          </p:stCondLst>
+                                        </p:cTn>
+                                        <p:tgtEl>
+                                          <p:spTgt spid="16"/>
+                                        </p:tgtEl>
+                                        <p:attrNameLst>
+                                          <p:attrName>style.visibility</p:attrName>
+                                        </p:attrNameLst>
+                                      </p:cBhvr>
+                                      <p:to>
+                                        <p:strVal val="visible"/>
+                                      </p:to>
+                                    </p:set>
+                                  </p:childTnLst>
+                                </p:cTn>
+                              </p:par>
+                            </p:childTnLst>
+                          </p:cTn>
+                        </p:par>
+                      </p:childTnLst>
+                    </p:cTn>
+                  </p:par>
+                  <p:par>
+                    <p:cTn id="7" fill="hold">
+                      <p:stCondLst>
+                        <p:cond delay="indefinite"/>
+                      </p:stCondLst>
+                      <p:childTnLst>
+                        <p:par>
+                          <p:cTn id="8" fill="hold">
+                            <p:stCondLst>
+                              <p:cond delay="0"/>
+                            </p:stCondLst>
+                            <p:childTnLst>
+                              <p:par>
+                                <p:cTn id="10" presetID="1" presetClass="entr" presetSubtype="0" fill="hold" grpId="0" nodeType="clickEffect">
+                                  <p:stCondLst>
+                                    <p:cond delay="0"/>
+                                  </p:stCondLst>
+                                  <p:childTnLst>
+                                    <p:set>
+                                      <p:cBhvr>
+                                        <p:cTn id="9" dur="1" fill="hold">
+                                          <p:stCondLst>
+                                            <p:cond delay="0"/>
+                                          </p:stCondLst>
+                                        </p:cTn>
+                                        <p:tgtEl>
+                                          <p:spTgt spid="19"/>
+                                        </p:tgtEl>
+                                        <p:attrNameLst>
+                                          <p:attrName>style.visibility</p:attrName>
+                                        </p:attrNameLst>
+                                      </p:cBhvr>
+                                      <p:to>
+                                        <p:strVal val="visible"/>
+                                      </p:to>
+                                    </p:set>
+                                  </p:childTnLst>
+                                </p:cTn>
+                              </p:par>
+                            </p:childTnLst>
+                          </p:cTn>
+                        </p:par>
+                      </p:childTnLst>
+                    </p:cTn>
+                  </p:par>
+                  <p:par>
+                    <p:cTn id="11" fill="hold">
+                      <p:stCondLst>
+                        <p:cond delay="indefinite"/>
+                      </p:stCondLst>
+                      <p:childTnLst>
+                        <p:par>
+                          <p:cTn id="12" fill="hold">
+                            <p:stCondLst>
+                              <p:cond delay="0"/>
+                            </p:stCondLst>
+                            <p:childTnLst>
+                              <p:par>
+                                <p:cTn id="14" presetID="1" presetClass="entr" presetSubtype="0" fill="hold" grpId="0" nodeType="clickEffect">
+                                  <p:stCondLst>
+                                    <p:cond delay="0"/>
+                                  </p:stCondLst>
+                                  <p:childTnLst>
+                                    <p:set>
+                                      <p:cBhvr>
+                                        <p:cTn id="13" dur="1" fill="hold">
+                                          <p:stCondLst>
+                                            <p:cond delay="0"/>
+                                          </p:stCondLst>
+                                        </p:cTn>
+                                        <p:tgtEl>
+                                          <p:spTgt spid="22"/>
+                                        </p:tgtEl>
+                                        <p:attrNameLst>
+                                          <p:attrName>style.visibility</p:attrName>
+                                        </p:attrNameLst>
+                                      </p:cBhvr>
+                                      <p:to>
+                                        <p:strVal val="visible"/>
+                                      </p:to>
+                                    </p:set>
+                                  </p:childTnLst>
+                                </p:cTn>
+                              </p:par>
+                            </p:childTnLst>
+                          </p:cTn>
+                        </p:par>
+                      </p:childTnLst>
+                    </p:cTn>
+                  </p:par>
+                  <p:par>
+                    <p:cTn id="15" fill="hold">
+                      <p:stCondLst>
+                        <p:cond delay="indefinite"/>
+                      </p:stCondLst>
+                      <p:childTnLst>
+                        <p:par>
+                          <p:cTn id="16" fill="hold">
+                            <p:stCondLst>
+                              <p:cond delay="0"/>
+                            </p:stCondLst>
+                            <p:childTnLst>
+                              <p:par>
+                                <p:cTn id="18" presetID="1" presetClass="entr" presetSubtype="0" fill="hold" grpId="0" nodeType="clickEffect">
+                                  <p:stCondLst>
+                                    <p:cond delay="0"/>
+                                  </p:stCondLst>
+                                  <p:childTnLst>
+                                    <p:set>
+                                      <p:cBhvr>
+                                        <p:cTn id="17" dur="1" fill="hold">
+                                          <p:stCondLst>
+                                            <p:cond delay="0"/>
+                                          </p:stCondLst>
+                                        </p:cTn>
+                                        <p:tgtEl>
+                                          <p:spTgt spid="23"/>
+                                        </p:tgtEl>
+                                        <p:attrNameLst>
+                                          <p:attrName>style.visibility</p:attrName>
+                                        </p:attrNameLst>
+                                      </p:cBhvr>
+                                      <p:to>
+                                        <p:strVal val="visible"/>
+                                      </p:to>
+                                    </p:set>
+                                  </p:childTnLst>
+                                </p:cTn>
+                              </p:par>
+                              <p:par>
+                                <p:cTn id="20" presetID="1" presetClass="entr" presetSubtype="0" fill="hold" grpId="0" nodeType="withEffect">
+                                  <p:stCondLst>
+                                    <p:cond delay="0"/>
+                                  </p:stCondLst>
+                                  <p:childTnLst>
+                                    <p:set>
+                                      <p:cBhvr>
+                                        <p:cTn id="19" dur="1" fill="hold">
+                                          <p:stCondLst>
+                                            <p:cond delay="0"/>
+                                          </p:stCondLst>
+                                        </p:cTn>
+                                        <p:tgtEl>
+                                          <p:spTgt spid="24"/>
+                                        </p:tgtEl>
+                                        <p:attrNameLst>
+                                          <p:attrName>style.visibility</p:attrName>
+                                        </p:attrNameLst>
+                                      </p:cBhvr>
+                                      <p:to>
+                                        <p:strVal val="visible"/>
+                                      </p:to>
+                                    </p:set>
+                                  </p:childTnLst>
+                                </p:cTn>
+                              </p:par>
+                              <p:par>
+                                <p:cTn id="22" presetID="1" presetClass="entr" presetSubtype="0" fill="hold" nodeType="withEffect">
+                                  <p:stCondLst>
+                                    <p:cond delay="0"/>
+                                  </p:stCondLst>
+                                  <p:childTnLst>
+                                    <p:set>
+                                      <p:cBhvr>
+                                        <p:cTn id="21" dur="1" fill="hold">
+                                          <p:stCondLst>
+                                            <p:cond delay="0"/>
+                                          </p:stCondLst>
+                                        </p:cTn>
+                                        <p:tgtEl>
+                                          <p:spTgt spid="25"/>
+                                        </p:tgtEl>
+                                        <p:attrNameLst>
+                                          <p:attrName>style.visibility</p:attrName>
+                                        </p:attrNameLst>
+                                      </p:cBhvr>
+                                      <p:to>
+                                        <p:strVal val="visible"/>
+                                      </p:to>
+                                    </p:set>
+                                  </p:childTnLst>
+                                </p:cTn>
+                              </p:par>
+                              <p:par>
+                                <p:cTn id="24" presetID="1" presetClass="entr" presetSubtype="0" fill="hold" grpId="0" nodeType="withEffect">
+                                  <p:stCondLst>
+                                    <p:cond delay="0"/>
+                                  </p:stCondLst>
+                                  <p:childTnLst>
+                                    <p:set>
+                                      <p:cBhvr>
+                                        <p:cTn id="23" dur="1" fill="hold">
+                                          <p:stCondLst>
+                                            <p:cond delay="0"/>
+                                          </p:stCondLst>
+                                        </p:cTn>
+                                        <p:tgtEl>
+                                          <p:spTgt spid="26"/>
+                                        </p:tgtEl>
+                                        <p:attrNameLst>
+                                          <p:attrName>style.visibility</p:attrName>
+                                        </p:attrNameLst>
+                                      </p:cBhvr>
+                                      <p:to>
+                                        <p:strVal val="visible"/>
+                                      </p:to>
+                                    </p:set>
+                                  </p:childTnLst>
+                                </p:cTn>
+                              </p:par>
+                            </p:childTnLst>
+                          </p:cTn>
+                        </p:par>
+                      </p:childTnLst>
+                    </p:cTn>
+                  </p:par>
+                </p:childTnLst>
+              </p:cTn>
+              <p:prevCondLst>
+                <p:cond evt="onPrev" delay="0">
+                  <p:tgtEl>
+                    <p:sldTgt/>
+                  </p:tgtEl>
+                </p:cond>
+              </p:prevCondLst>
+              <p:nextCondLst>
+                <p:cond evt="onNext" delay="0">
+                  <p:tgtEl>
+                    <p:sldTgt/>
+                  </p:tgtEl>
+                </p:cond>
+              </p:nextCondLst>
+            </p:seq>
+          </p:childTnLst>
+        </p:cTn>
+      </p:par>
+    </p:tnLst>
+    <p:bldLst>
+      <p:bldP spid="16" grpId="0" animBg="1"/>
+      <p:bldP spid="19" grpId="0" animBg="1"/>
+      <p:bldP spid="22" grpId="0" animBg="1"/>
+      <p:bldP spid="23" grpId="0" animBg="1"/>
+      <p:bldP spid="24" grpId="0" animBg="1"/>
+      <p:bldP spid="26" grpId="0" animBg="1"/>
+    </p:bldLst>
+  </p:timing>
 </p:sld>
 </file>
 

</xml_diff>